<commit_message>
Update GitHub repo URL in docx, pptx and submission scripts
</commit_message>
<xml_diff>
--- a/DangQuocThanhTai_Bao_cao_cuoi_ky.pptx
+++ b/DangQuocThanhTai_Bao_cao_cuoi_ky.pptx
@@ -3298,51 +3298,23 @@
           </a:bodyPr>
           <a:lstStyle/>
           <a:p>
-            <a:pPr>
-              <a:defRPr sz="1300" b="1">
-                <a:solidFill>
-                  <a:srgbClr val="102C57"/>
-                </a:solidFill>
-              </a:defRPr>
-            </a:pPr>
             <a:r>
               <a:t>Sinh viên thực hiện:  ĐẶNG QUỐC THÀNH TÀI  -  MSSV: 23110149  (Lớp: 261AIOT331185_01CLC)</a:t>
             </a:r>
           </a:p>
           <a:p>
-            <a:pPr>
-              <a:defRPr sz="1300" b="1">
-                <a:solidFill>
-                  <a:srgbClr val="1E1E1E"/>
-                </a:solidFill>
-              </a:defRPr>
-            </a:pPr>
             <a:r>
               <a:t>Giảng viên hướng dẫn:  ThS/TS. HỒ NHỰT MINH</a:t>
             </a:r>
           </a:p>
           <a:p>
-            <a:pPr>
-              <a:defRPr sz="1200">
-                <a:solidFill>
-                  <a:srgbClr val="505050"/>
-                </a:solidFill>
-              </a:defRPr>
-            </a:pPr>
             <a:r>
               <a:t>Bộ dữ liệu thực nghiệm:  Free Spoken Digit Dataset (FSDD - 3.000 file WAV mono 8 kHz)</a:t>
             </a:r>
           </a:p>
           <a:p>
-            <a:pPr>
-              <a:defRPr sz="1200">
-                <a:solidFill>
-                  <a:srgbClr val="3572EF"/>
-                </a:solidFill>
-              </a:defRPr>
-            </a:pPr>
-            <a:r>
-              <a:t>Mã nguồn GitHub:  https://github.com/DangQuocThanhTai/cvae-spoken-digit-tstr</a:t>
+            <a:r>
+              <a:t>Mã nguồn GitHub:  https://github.com/dqtt2005/DANGQUOCTHANHTAI_final</a:t>
             </a:r>
           </a:p>
         </p:txBody>

</xml_diff>